<commit_message>
feat: standardize big-screen typography into scripts/ and enforce in agent.md
</commit_message>
<xml_diff>
--- a/新北市二橋國小_數位工具教與學_2小時到校輔導教案簡報.pptx
+++ b/新北市二橋國小_數位工具教與學_2小時到校輔導教案簡報.pptx
@@ -3219,6 +3219,7 @@
               </a:defRPr>
             </a:pPr>
             <a:r>
+              <a:rPr/>
               <a:t>新北市學習共同體輔導團｜入校輔導專案</a:t>
             </a:r>
           </a:p>
@@ -3235,10 +3236,12 @@
               </a:defRPr>
             </a:pPr>
             <a:r>
+              <a:rPr/>
               <a:t>新北市二橋國小「數位工具教與學」</a:t>
             </a:r>
             <a:br/>
             <a:r>
+              <a:rPr/>
               <a:t>2 小時到校輔導課程設計教案</a:t>
             </a:r>
           </a:p>
@@ -3255,6 +3258,7 @@
               </a:defRPr>
             </a:pPr>
             <a:r>
+              <a:rPr/>
               <a:t>🎯 依據 19 位全校教師問卷診斷・破除載具分心・AI 命製跳躍任務</a:t>
             </a:r>
           </a:p>
@@ -3268,10 +3272,12 @@
               </a:defRPr>
             </a:pPr>
             <a:r>
+              <a:rPr/>
               <a:t>研習對象：新北市二橋國小全體教師　｜　研習時間：120 分鐘（實作工作坊）</a:t>
             </a:r>
             <a:br/>
             <a:r>
+              <a:rPr/>
               <a:t>教案規劃：新北市學習共同體輔導團　｜　數據來源：115數位工具前置調查</a:t>
             </a:r>
           </a:p>
@@ -3395,6 +3401,7 @@
               </a:defRPr>
             </a:pPr>
             <a:r>
+              <a:rPr/>
               <a:t>攜手二橋・課後落地有保障</a:t>
             </a:r>
           </a:p>
@@ -3408,6 +3415,7 @@
               </a:defRPr>
             </a:pPr>
             <a:r>
+              <a:rPr/>
               <a:t>🎁 研習交付成果與課後陪伴資源</a:t>
             </a:r>
           </a:p>
@@ -3492,6 +3500,7 @@
               </a:defRPr>
             </a:pPr>
             <a:r>
+              <a:rPr/>
               <a:t>📦 成果一：即戰力教案現場產出</a:t>
             </a:r>
           </a:p>
@@ -3505,6 +3514,7 @@
               </a:defRPr>
             </a:pPr>
             <a:r>
+              <a:rPr/>
               <a:t>每位參與研習的老師，在 40 分鐘實作中現場完成 1 份下週就能直接進班上陣的學共伸展跳躍任務教案！</a:t>
             </a:r>
           </a:p>
@@ -3589,6 +3599,7 @@
               </a:defRPr>
             </a:pPr>
             <a:r>
+              <a:rPr/>
               <a:t>🪄 成果二：二橋專屬 AI 提示詞速查卡</a:t>
             </a:r>
           </a:p>
@@ -3602,6 +3613,7 @@
               </a:defRPr>
             </a:pPr>
             <a:r>
+              <a:rPr/>
               <a:t>提供二橋教師專屬《學共 AI 備課提示詞手冊》，包含國語閱讀理解、數學多解探究之標準 Prompt。</a:t>
             </a:r>
           </a:p>
@@ -3686,6 +3698,7 @@
               </a:defRPr>
             </a:pPr>
             <a:r>
+              <a:rPr/>
               <a:t>📋 成果三：學共載具班級常規檢核表</a:t>
             </a:r>
           </a:p>
@@ -3699,6 +3712,7 @@
               </a:defRPr>
             </a:pPr>
             <a:r>
+              <a:rPr/>
               <a:t>提供低年級與中高年級適用的課堂常規檢核清單（螢幕蓋板三步驟口令、4人小組分工合作指標）。</a:t>
             </a:r>
           </a:p>
@@ -3783,6 +3797,7 @@
               </a:defRPr>
             </a:pPr>
             <a:r>
+              <a:rPr/>
               <a:t>🤝 成果四：輔導團雲端資源庫持續陪伴</a:t>
             </a:r>
           </a:p>
@@ -3796,6 +3811,7 @@
               </a:defRPr>
             </a:pPr>
             <a:r>
+              <a:rPr/>
               <a:t>建立二橋國小專屬雲端硬碟，講師示範簡報、Padlet 範本、觀課議課實例影片持續共享與支持更新。</a:t>
             </a:r>
           </a:p>
@@ -3898,6 +3914,7 @@
               </a:defRPr>
             </a:pPr>
             <a:r>
+              <a:rPr/>
               <a:t>學習共同體輔導團・2小時到校輔導教案</a:t>
             </a:r>
           </a:p>
@@ -3911,6 +3928,7 @@
               </a:defRPr>
             </a:pPr>
             <a:r>
+              <a:rPr/>
               <a:t>二橋國小學情診斷：全校教師四大關鍵畫像</a:t>
             </a:r>
           </a:p>
@@ -4019,6 +4037,7 @@
               </a:defRPr>
             </a:pPr>
             <a:r>
+              <a:rPr/>
               <a:t>👥 年段極均衡</a:t>
             </a:r>
           </a:p>
@@ -4035,6 +4054,7 @@
               </a:defRPr>
             </a:pPr>
             <a:r>
+              <a:rPr/>
               <a:t>19 位</a:t>
             </a:r>
           </a:p>
@@ -4051,6 +4071,7 @@
               </a:defRPr>
             </a:pPr>
             <a:r>
+              <a:rPr/>
               <a:t>低年級 4 位 (21%)</a:t>
             </a:r>
           </a:p>
@@ -4067,6 +4088,7 @@
               </a:defRPr>
             </a:pPr>
             <a:r>
+              <a:rPr/>
               <a:t>中年級 4 位 (21%)</a:t>
             </a:r>
           </a:p>
@@ -4083,6 +4105,7 @@
               </a:defRPr>
             </a:pPr>
             <a:r>
+              <a:rPr/>
               <a:t>高年級 4 位 (21%)</a:t>
             </a:r>
           </a:p>
@@ -4099,6 +4122,7 @@
               </a:defRPr>
             </a:pPr>
             <a:r>
+              <a:rPr/>
               <a:t>行政科任 7 位 (37%)</a:t>
             </a:r>
           </a:p>
@@ -4115,6 +4139,7 @@
               </a:defRPr>
             </a:pPr>
             <a:r>
+              <a:rPr/>
               <a:t>★ 研習兼顧跨學段彈性</a:t>
             </a:r>
           </a:p>
@@ -4199,6 +4224,7 @@
               </a:defRPr>
             </a:pPr>
             <a:r>
+              <a:rPr/>
               <a:t>🏆 資深骨幹主力</a:t>
             </a:r>
           </a:p>
@@ -4215,6 +4241,7 @@
               </a:defRPr>
             </a:pPr>
             <a:r>
+              <a:rPr/>
               <a:t>95%</a:t>
             </a:r>
           </a:p>
@@ -4231,6 +4258,7 @@
               </a:defRPr>
             </a:pPr>
             <a:r>
+              <a:rPr/>
               <a:t>21年以上資深 7 位 (37%)</a:t>
             </a:r>
           </a:p>
@@ -4247,6 +4275,7 @@
               </a:defRPr>
             </a:pPr>
             <a:r>
+              <a:rPr/>
               <a:t>中生代教師 6 位 (32%)</a:t>
             </a:r>
           </a:p>
@@ -4263,6 +4292,7 @@
               </a:defRPr>
             </a:pPr>
             <a:r>
+              <a:rPr/>
               <a:t>資深教師 5 位 (26%)</a:t>
             </a:r>
           </a:p>
@@ -4279,6 +4309,7 @@
               </a:defRPr>
             </a:pPr>
             <a:r>
+              <a:rPr/>
               <a:t>★ 教學底蘊極深厚</a:t>
             </a:r>
           </a:p>
@@ -4363,6 +4394,7 @@
               </a:defRPr>
             </a:pPr>
             <a:r>
+              <a:rPr/>
               <a:t>🖥️ 關鍵硬體王牌</a:t>
             </a:r>
           </a:p>
@@ -4379,6 +4411,7 @@
               </a:defRPr>
             </a:pPr>
             <a:r>
+              <a:rPr/>
               <a:t>100%</a:t>
             </a:r>
           </a:p>
@@ -4395,6 +4428,7 @@
               </a:defRPr>
             </a:pPr>
             <a:r>
+              <a:rPr/>
               <a:t>全校 19 班均內建</a:t>
             </a:r>
           </a:p>
@@ -4411,6 +4445,7 @@
               </a:defRPr>
             </a:pPr>
             <a:r>
+              <a:rPr/>
               <a:t>86 吋大型觸控螢幕！</a:t>
             </a:r>
           </a:p>
@@ -4427,6 +4462,7 @@
               </a:defRPr>
             </a:pPr>
             <a:r>
+              <a:rPr/>
               <a:t>(平板抽用或生生用)</a:t>
             </a:r>
           </a:p>
@@ -4443,6 +4479,7 @@
               </a:defRPr>
             </a:pPr>
             <a:r>
+              <a:rPr/>
               <a:t>★ 重點在大螢幕共構</a:t>
             </a:r>
           </a:p>
@@ -4527,6 +4564,7 @@
               </a:defRPr>
             </a:pPr>
             <a:r>
+              <a:rPr/>
               <a:t>📱 載具使用頻率</a:t>
             </a:r>
           </a:p>
@@ -4543,6 +4581,7 @@
               </a:defRPr>
             </a:pPr>
             <a:r>
+              <a:rPr/>
               <a:t>雙峰分佈</a:t>
             </a:r>
           </a:p>
@@ -4559,6 +4598,7 @@
               </a:defRPr>
             </a:pPr>
             <a:r>
+              <a:rPr/>
               <a:t>每週4次以上：37%</a:t>
             </a:r>
           </a:p>
@@ -4575,6 +4615,7 @@
               </a:defRPr>
             </a:pPr>
             <a:r>
+              <a:rPr/>
               <a:t>每月1-2次：26%</a:t>
             </a:r>
           </a:p>
@@ -4591,6 +4632,7 @@
               </a:defRPr>
             </a:pPr>
             <a:r>
+              <a:rPr/>
               <a:t>偶爾使用：16%</a:t>
             </a:r>
           </a:p>
@@ -4607,6 +4649,7 @@
               </a:defRPr>
             </a:pPr>
             <a:r>
+              <a:rPr/>
               <a:t>★ 高頻與少用並存</a:t>
             </a:r>
           </a:p>
@@ -4709,6 +4752,7 @@
               </a:defRPr>
             </a:pPr>
             <a:r>
+              <a:rPr/>
               <a:t>學習共同體輔導團・2小時到校輔導教案</a:t>
             </a:r>
           </a:p>
@@ -4722,6 +4766,7 @@
               </a:defRPr>
             </a:pPr>
             <a:r>
+              <a:rPr/>
               <a:t>二橋三大痛點魔王 vs 模組票選期待 Top 3</a:t>
             </a:r>
           </a:p>
@@ -4830,6 +4875,7 @@
               </a:defRPr>
             </a:pPr>
             <a:r>
+              <a:rPr/>
               <a:t>🚨 二橋教師最大的三個課堂卡點</a:t>
             </a:r>
           </a:p>
@@ -4846,6 +4892,7 @@
               </a:defRPr>
             </a:pPr>
             <a:r>
+              <a:rPr/>
               <a:t>1. 載具分心與破壞傾聽 (53%)</a:t>
             </a:r>
           </a:p>
@@ -4862,6 +4909,7 @@
               </a:defRPr>
             </a:pPr>
             <a:r>
+              <a:rPr/>
               <a:t>玩遊戲、發呆、不聽發言；螢幕亮著時眼神不再注視同伴。</a:t>
             </a:r>
           </a:p>
@@ -4878,6 +4926,7 @@
               </a:defRPr>
             </a:pPr>
             <a:r>
+              <a:rPr/>
               <a:t>2. 操作載具耗時太久 (47%)</a:t>
             </a:r>
           </a:p>
@@ -4894,6 +4943,7 @@
               </a:defRPr>
             </a:pPr>
             <a:r>
+              <a:rPr/>
               <a:t>帳號登入繁瑣、連線不穩；搞載具嚴重壓縮小組深思時間！</a:t>
             </a:r>
           </a:p>
@@ -4910,6 +4960,7 @@
               </a:defRPr>
             </a:pPr>
             <a:r>
+              <a:rPr/>
               <a:t>3. 跳躍題設計缺乏指引 (32%)</a:t>
             </a:r>
           </a:p>
@@ -4926,6 +4977,7 @@
               </a:defRPr>
             </a:pPr>
             <a:r>
+              <a:rPr/>
               <a:t>不知道如何結合數位設計高挑戰題（跳躍題信心僅 2.68 分）。</a:t>
             </a:r>
           </a:p>
@@ -5010,6 +5062,7 @@
               </a:defRPr>
             </a:pPr>
             <a:r>
+              <a:rPr/>
               <a:t>🎯 研習實作模組期待排行 Top 3</a:t>
             </a:r>
           </a:p>
@@ -5026,6 +5079,7 @@
               </a:defRPr>
             </a:pPr>
             <a:r>
+              <a:rPr/>
               <a:t>🥇 【模組A】AI 命製跳躍任務 (10票 / 53%)</a:t>
             </a:r>
           </a:p>
@@ -5042,6 +5096,7 @@
               </a:defRPr>
             </a:pPr>
             <a:r>
+              <a:rPr/>
               <a:t>用 Gemini / NotebookLM 備課，3分鐘產出高層次跳躍題。</a:t>
             </a:r>
           </a:p>
@@ -5058,6 +5113,7 @@
               </a:defRPr>
             </a:pPr>
             <a:r>
+              <a:rPr/>
               <a:t>🥈 【模組B】Padlet 共學互學神器 (9票 / 47%)</a:t>
             </a:r>
           </a:p>
@@ -5074,6 +5130,7 @@
               </a:defRPr>
             </a:pPr>
             <a:r>
+              <a:rPr/>
               <a:t>免付費互動牆，小組討論一鍵張貼，串聯大螢幕共構。</a:t>
             </a:r>
           </a:p>
@@ -5090,6 +5147,7 @@
               </a:defRPr>
             </a:pPr>
             <a:r>
+              <a:rPr/>
               <a:t>🥉 【模組D】破除分心班級經營 (8票 / 42%)</a:t>
             </a:r>
           </a:p>
@@ -5106,6 +5164,7 @@
               </a:defRPr>
             </a:pPr>
             <a:r>
+              <a:rPr/>
               <a:t>螢幕反轉法與免登入快速常規，把時間還給學生對話！</a:t>
             </a:r>
           </a:p>
@@ -5208,6 +5267,7 @@
               </a:defRPr>
             </a:pPr>
             <a:r>
+              <a:rPr/>
               <a:t>學習共同體輔導團・2小時到校輔導教案</a:t>
             </a:r>
           </a:p>
@@ -5221,6 +5281,7 @@
               </a:defRPr>
             </a:pPr>
             <a:r>
+              <a:rPr/>
               <a:t>課程指導心法：二橋專屬破局三策</a:t>
             </a:r>
           </a:p>
@@ -5329,6 +5390,7 @@
               </a:defRPr>
             </a:pPr>
             <a:r>
+              <a:rPr/>
               <a:t>策略一：常規先行</a:t>
             </a:r>
           </a:p>
@@ -5345,6 +5407,7 @@
               </a:defRPr>
             </a:pPr>
             <a:r>
+              <a:rPr/>
               <a:t>守護實體傾聽</a:t>
             </a:r>
           </a:p>
@@ -5361,6 +5424,7 @@
               </a:defRPr>
             </a:pPr>
             <a:r>
+              <a:rPr/>
               <a:t>• 實踐『三秒蓋板 / 螢幕反轉』：發言時眼看同伴，載具平放。</a:t>
             </a:r>
           </a:p>
@@ -5377,6 +5441,7 @@
               </a:defRPr>
             </a:pPr>
             <a:r>
+              <a:rPr/>
               <a:t>• 免帳號極速入場：QR-Code 一掃即進，登入由 10分鐘壓到 30秒。</a:t>
             </a:r>
           </a:p>
@@ -5393,6 +5458,7 @@
               </a:defRPr>
             </a:pPr>
             <a:r>
+              <a:rPr/>
               <a:t>• 平板是『思維筆記本』，守護課堂溫潤眼神對話。</a:t>
             </a:r>
           </a:p>
@@ -5477,6 +5543,7 @@
               </a:defRPr>
             </a:pPr>
             <a:r>
+              <a:rPr/>
               <a:t>策略二：善用 86吋大屏</a:t>
             </a:r>
           </a:p>
@@ -5493,6 +5560,7 @@
               </a:defRPr>
             </a:pPr>
             <a:r>
+              <a:rPr/>
               <a:t>告別個別孤島</a:t>
             </a:r>
           </a:p>
@@ -5509,6 +5577,7 @@
               </a:defRPr>
             </a:pPr>
             <a:r>
+              <a:rPr/>
               <a:t>• 不推生生用平板各自孤立，改以 4人一組共用 1 載具共學。</a:t>
             </a:r>
           </a:p>
@@ -5525,6 +5594,7 @@
               </a:defRPr>
             </a:pPr>
             <a:r>
+              <a:rPr/>
               <a:t>• 各組多元解法一秒推播至黑板 86 吋觸控大螢幕。</a:t>
             </a:r>
           </a:p>
@@ -5541,6 +5611,7 @@
               </a:defRPr>
             </a:pPr>
             <a:r>
+              <a:rPr/>
               <a:t>• 教師在大屏圈選、對比，促發全班高階共構對話。</a:t>
             </a:r>
           </a:p>
@@ -5625,6 +5696,7 @@
               </a:defRPr>
             </a:pPr>
             <a:r>
+              <a:rPr/>
               <a:t>策略三：AI 命題跳躍題</a:t>
             </a:r>
           </a:p>
@@ -5641,6 +5713,7 @@
               </a:defRPr>
             </a:pPr>
             <a:r>
+              <a:rPr/>
               <a:t>突破 2.68分信心瓶頸</a:t>
             </a:r>
           </a:p>
@@ -5657,6 +5730,7 @@
               </a:defRPr>
             </a:pPr>
             <a:r>
+              <a:rPr/>
               <a:t>• 課本單元丟給 AI，3分鐘解構文本三層次思維。</a:t>
             </a:r>
           </a:p>
@@ -5673,6 +5747,7 @@
               </a:defRPr>
             </a:pPr>
             <a:r>
+              <a:rPr/>
               <a:t>• 產出具備認知衝突的『伸展跳躍任務 (Jumping Task)』。</a:t>
             </a:r>
           </a:p>
@@ -5689,6 +5764,7 @@
               </a:defRPr>
             </a:pPr>
             <a:r>
+              <a:rPr/>
               <a:t>• 研習現場實作，每位老師帶走下週立即可用的教案！</a:t>
             </a:r>
           </a:p>
@@ -5791,6 +5867,7 @@
               </a:defRPr>
             </a:pPr>
             <a:r>
+              <a:rPr/>
               <a:t>學習共同體輔導團・2小時到校輔導教案</a:t>
             </a:r>
           </a:p>
@@ -5804,6 +5881,7 @@
               </a:defRPr>
             </a:pPr>
             <a:r>
+              <a:rPr/>
               <a:t>2小時工作坊教案流程總覽（起承轉合）</a:t>
             </a:r>
           </a:p>
@@ -6185,7 +6263,7 @@
                     </a:p>
                     <a:p>
                       <a:r>
-                        <a:t>破除學生分心</a:t>
+                        <a:t>破除載具分心</a:t>
                       </a:r>
                     </a:p>
                   </a:txBody>
@@ -6661,6 +6739,7 @@
               </a:defRPr>
             </a:pPr>
             <a:r>
+              <a:rPr/>
               <a:t>學習共同體輔導團・2小時到校輔導教案</a:t>
             </a:r>
           </a:p>
@@ -6674,6 +6753,7 @@
               </a:defRPr>
             </a:pPr>
             <a:r>
+              <a:rPr/>
               <a:t>模組 D 落地實務：破除分心與學共載具常規</a:t>
             </a:r>
           </a:p>
@@ -6782,6 +6862,7 @@
               </a:defRPr>
             </a:pPr>
             <a:r>
+              <a:rPr/>
               <a:t>一、 根絕『耗時15分鐘』的極速登入常規</a:t>
             </a:r>
           </a:p>
@@ -6798,6 +6879,7 @@
               </a:defRPr>
             </a:pPr>
             <a:r>
+              <a:rPr/>
               <a:t>• 傳統痛點：學生忘記帳號密碼、大小寫分不清，搞登入消耗半堂課！</a:t>
             </a:r>
           </a:p>
@@ -6814,6 +6896,7 @@
               </a:defRPr>
             </a:pPr>
             <a:r>
+              <a:rPr/>
               <a:t>• 解決對策：全面採用『零登入 / 免帳號 QR-Code』與短網址代碼直達。</a:t>
             </a:r>
           </a:p>
@@ -6830,6 +6913,7 @@
               </a:defRPr>
             </a:pPr>
             <a:r>
+              <a:rPr/>
               <a:t>• 課堂成效：開機掃描 30 秒進入討論情境，把完整時間還給學生深度對話！</a:t>
             </a:r>
           </a:p>
@@ -6914,6 +6998,7 @@
               </a:defRPr>
             </a:pPr>
             <a:r>
+              <a:rPr/>
               <a:t>二、 守護眼神與語言的『三秒蓋板三步驟』</a:t>
             </a:r>
           </a:p>
@@ -6930,6 +7015,7 @@
               </a:defRPr>
             </a:pPr>
             <a:r>
+              <a:rPr/>
               <a:t>• 步驟 1【倒數指令】：口令『3、2、1，螢幕蓋板』，全班動作一致。</a:t>
             </a:r>
           </a:p>
@@ -6946,6 +7032,7 @@
               </a:defRPr>
             </a:pPr>
             <a:r>
+              <a:rPr/>
               <a:t>• 步驟 2【姿態重置】：平板面朝下平放桌角，雙手自然置於桌面，停止滑動。</a:t>
             </a:r>
           </a:p>
@@ -6962,6 +7049,7 @@
               </a:defRPr>
             </a:pPr>
             <a:r>
+              <a:rPr/>
               <a:t>• 步驟 3【視線聚焦】：雙眼抬起注視發言夥伴，啟動高專注實體傾聽關係。</a:t>
             </a:r>
           </a:p>
@@ -7046,6 +7134,7 @@
               </a:defRPr>
             </a:pPr>
             <a:r>
+              <a:rPr/>
               <a:t>三、 低年級學童的『防卡關三法寶』</a:t>
             </a:r>
           </a:p>
@@ -7062,6 +7151,7 @@
               </a:defRPr>
             </a:pPr>
             <a:r>
+              <a:rPr/>
               <a:t>• 法寶 1【顏色組別平板】：背貼大面積紅/藍/黃/綠標籤，依組領取不分個人機。</a:t>
             </a:r>
           </a:p>
@@ -7078,6 +7168,7 @@
               </a:defRPr>
             </a:pPr>
             <a:r>
+              <a:rPr/>
               <a:t>• 法寶 2【免注音打字】：引導學生按下麥克風語音輸入，或拍下小白板實體操作。</a:t>
             </a:r>
           </a:p>
@@ -7094,6 +7185,7 @@
               </a:defRPr>
             </a:pPr>
             <a:r>
+              <a:rPr/>
               <a:t>• 法寶 3【單一桌面捷徑】：桌面僅留一個當日任務網頁捷徑，點開直接開始。</a:t>
             </a:r>
           </a:p>
@@ -7196,6 +7288,7 @@
               </a:defRPr>
             </a:pPr>
             <a:r>
+              <a:rPr/>
               <a:t>學習共同體輔導團・2小時到校輔導教案</a:t>
             </a:r>
           </a:p>
@@ -7209,6 +7302,7 @@
               </a:defRPr>
             </a:pPr>
             <a:r>
+              <a:rPr/>
               <a:t>模組 B 落地實務：Padlet 小組共學與 86吋大屏共構</a:t>
             </a:r>
           </a:p>
@@ -7317,6 +7411,7 @@
               </a:defRPr>
             </a:pPr>
             <a:r>
+              <a:rPr/>
               <a:t>📱 小組輕量共學：4人共用 1 載具</a:t>
             </a:r>
           </a:p>
@@ -7333,6 +7428,7 @@
               </a:defRPr>
             </a:pPr>
             <a:r>
+              <a:rPr/>
               <a:t>為什麼不推生生用平板？</a:t>
             </a:r>
           </a:p>
@@ -7349,6 +7445,7 @@
               </a:defRPr>
             </a:pPr>
             <a:r>
+              <a:rPr/>
               <a:t>人手一台容易陷入『各自孤島』，各滑各的，完全沒有真正的傾聽與對話！</a:t>
             </a:r>
           </a:p>
@@ -7365,6 +7462,7 @@
               </a:defRPr>
             </a:pPr>
             <a:r>
+              <a:rPr/>
               <a:t>4人共用 1 載具的協作魔力：</a:t>
             </a:r>
           </a:p>
@@ -7381,7 +7479,8 @@
               </a:defRPr>
             </a:pPr>
             <a:r>
-              <a:t>• 角色輪替：1 人負責操作記錄，其餘 3 人專注發想、檢核與質疑討論。</a:t>
+              <a:rPr/>
+              <a:t>• 角色輪替：1 人負責記錄，其餘 3 人專注發想、檢核與質疑討論。</a:t>
             </a:r>
           </a:p>
           <a:p>
@@ -7397,6 +7496,7 @@
               </a:defRPr>
             </a:pPr>
             <a:r>
+              <a:rPr/>
               <a:t>• 實體對話先行：組內必須先達成共識，才能由記錄者打字或拍照上傳。</a:t>
             </a:r>
           </a:p>
@@ -7413,6 +7513,7 @@
               </a:defRPr>
             </a:pPr>
             <a:r>
+              <a:rPr/>
               <a:t>• Padlet 零門檻張貼：小組將解法卡、疑惑卡一鍵張貼，隨時回溯思考軌跡。</a:t>
             </a:r>
           </a:p>
@@ -7497,6 +7598,7 @@
               </a:defRPr>
             </a:pPr>
             <a:r>
+              <a:rPr/>
               <a:t>🖥️ 86吋觸控大螢幕：思維可視化共構</a:t>
             </a:r>
           </a:p>
@@ -7513,6 +7615,7 @@
               </a:defRPr>
             </a:pPr>
             <a:r>
+              <a:rPr/>
               <a:t>全校 100% 內建大螢幕的最強戰術：</a:t>
             </a:r>
           </a:p>
@@ -7529,6 +7632,7 @@
               </a:defRPr>
             </a:pPr>
             <a:r>
+              <a:rPr/>
               <a:t>• 全班想法並列：大螢幕同時並列各組思考路徑，告別單組輪流報的枯燥。</a:t>
             </a:r>
           </a:p>
@@ -7545,6 +7649,7 @@
               </a:defRPr>
             </a:pPr>
             <a:r>
+              <a:rPr/>
               <a:t>• 觸控筆畫圈連線：教師與學生走上講台，直接在大屏圈出亮點與矛盾。</a:t>
             </a:r>
           </a:p>
@@ -7561,6 +7666,7 @@
               </a:defRPr>
             </a:pPr>
             <a:r>
+              <a:rPr/>
               <a:t>• 促發全班對話：『第 2 組和第 4 組有什麼不同？誰能看懂他們的想法？』</a:t>
             </a:r>
           </a:p>
@@ -7577,6 +7683,7 @@
               </a:defRPr>
             </a:pPr>
             <a:r>
+              <a:rPr/>
               <a:t>• 從作業升華為共構：大螢幕不是投影機，而是全班共同探究的大黑板！</a:t>
             </a:r>
           </a:p>
@@ -7679,6 +7786,7 @@
               </a:defRPr>
             </a:pPr>
             <a:r>
+              <a:rPr/>
               <a:t>學習共同體輔導團・2小時到校輔導教案</a:t>
             </a:r>
           </a:p>
@@ -7692,6 +7800,7 @@
               </a:defRPr>
             </a:pPr>
             <a:r>
+              <a:rPr/>
               <a:t>模組 A 落地實務：AI Agent 命製學共伸展跳躍任務</a:t>
             </a:r>
           </a:p>
@@ -7800,6 +7909,7 @@
               </a:defRPr>
             </a:pPr>
             <a:r>
+              <a:rPr/>
               <a:t>層次一：基礎提取題 (30%)</a:t>
             </a:r>
           </a:p>
@@ -7816,6 +7926,7 @@
               </a:defRPr>
             </a:pPr>
             <a:r>
+              <a:rPr/>
               <a:t>掌握課本事實、核心定義或基本算則。</a:t>
             </a:r>
           </a:p>
@@ -7832,6 +7943,7 @@
               </a:defRPr>
             </a:pPr>
             <a:r>
+              <a:rPr/>
               <a:t>• 例：主角遇到什麼困境？這題條件是什麼？</a:t>
             </a:r>
           </a:p>
@@ -7916,6 +8028,7 @@
               </a:defRPr>
             </a:pPr>
             <a:r>
+              <a:rPr/>
               <a:t>層次二：推論統整題 (60%)</a:t>
             </a:r>
           </a:p>
@@ -7932,6 +8045,7 @@
               </a:defRPr>
             </a:pPr>
             <a:r>
+              <a:rPr/>
               <a:t>小組互學探究因果關係與多元解法。</a:t>
             </a:r>
           </a:p>
@@ -7948,7 +8062,8 @@
               </a:defRPr>
             </a:pPr>
             <a:r>
-              <a:t>• 例：為什麼做此選擇？這兩種算式本質同嗎？</a:t>
+              <a:rPr/>
+              <a:t>• 例：為什麼做此選擇？兩種算式本質同嗎？</a:t>
             </a:r>
           </a:p>
         </p:txBody>
@@ -8032,6 +8147,7 @@
               </a:defRPr>
             </a:pPr>
             <a:r>
+              <a:rPr/>
               <a:t>層次三：伸展跳躍題 (100% Jumping Task)</a:t>
             </a:r>
           </a:p>
@@ -8048,7 +8164,8 @@
               </a:defRPr>
             </a:pPr>
             <a:r>
-              <a:t>高認知挑戰、開放思考、促發同儕相互借力！</a:t>
+              <a:rPr/>
+              <a:t>高認知挑戰、開放思考、促發同儕借力！</a:t>
             </a:r>
           </a:p>
           <a:p>
@@ -8064,6 +8181,7 @@
               </a:defRPr>
             </a:pPr>
             <a:r>
+              <a:rPr/>
               <a:t>• 例：如果結局翻轉，如何改寫？有何生活模型？</a:t>
             </a:r>
           </a:p>
@@ -8148,6 +8266,7 @@
               </a:defRPr>
             </a:pPr>
             <a:r>
+              <a:rPr/>
               <a:t>🪄 現場實作：二橋專屬 AI 跳躍任務命題咒語（複製貼上 Gemini / ChatGPT）</a:t>
             </a:r>
           </a:p>
@@ -8164,6 +8283,7 @@
               </a:defRPr>
             </a:pPr>
             <a:r>
+              <a:rPr/>
               <a:t>你是一位專精日本佐藤學『學習共同體』教學法的國小教材研發專家。</a:t>
             </a:r>
           </a:p>
@@ -8180,6 +8300,7 @@
               </a:defRPr>
             </a:pPr>
             <a:r>
+              <a:rPr/>
               <a:t>我目前要教授［科目/年級/單元名稱］，課本段落或核心概念如下：［貼上課文或概念］。</a:t>
             </a:r>
           </a:p>
@@ -8196,6 +8317,7 @@
               </a:defRPr>
             </a:pPr>
             <a:r>
+              <a:rPr/>
               <a:t>請為我設計：</a:t>
             </a:r>
           </a:p>
@@ -8212,6 +8334,7 @@
               </a:defRPr>
             </a:pPr>
             <a:r>
+              <a:rPr/>
               <a:t>1. 2 題小組共學互學探究題（促發學生提出不同觀察角度與深層對話）。</a:t>
             </a:r>
           </a:p>
@@ -8228,6 +8351,7 @@
               </a:defRPr>
             </a:pPr>
             <a:r>
+              <a:rPr/>
               <a:t>2. 1 題高挑戰度的『伸展跳躍任務 (Jumping Task)』（具備認知衝突、開放思考、非單一標準答案）。</a:t>
             </a:r>
           </a:p>
@@ -8244,6 +8368,7 @@
               </a:defRPr>
             </a:pPr>
             <a:r>
+              <a:rPr/>
               <a:t>3. 針對跳躍任務，提供老師 3 個課堂引導與追問的理答支架提問。</a:t>
             </a:r>
           </a:p>
@@ -8346,6 +8471,7 @@
               </a:defRPr>
             </a:pPr>
             <a:r>
+              <a:rPr/>
               <a:t>學習共同體輔導團・2小時到校輔導教案</a:t>
             </a:r>
           </a:p>
@@ -8359,6 +8485,7 @@
               </a:defRPr>
             </a:pPr>
             <a:r>
+              <a:rPr/>
               <a:t>二橋個別提問現場破解：低年級不卡關與互動小遊戲</a:t>
             </a:r>
           </a:p>
@@ -8464,6 +8591,7 @@
               </a:defRPr>
             </a:pPr>
             <a:r>
+              <a:rPr/>
               <a:t>❓ 低年級老師提問：</a:t>
             </a:r>
           </a:p>
@@ -8480,6 +8608,7 @@
               </a:defRPr>
             </a:pPr>
             <a:r>
+              <a:rPr/>
               <a:t>「低年級學生如何快速上手不卡關？」</a:t>
             </a:r>
           </a:p>
@@ -8496,6 +8625,7 @@
               </a:defRPr>
             </a:pPr>
             <a:r>
+              <a:rPr/>
               <a:t>💡 輔導團三階落地解方：</a:t>
             </a:r>
           </a:p>
@@ -8512,6 +8642,7 @@
               </a:defRPr>
             </a:pPr>
             <a:r>
+              <a:rPr/>
               <a:t>1. 【取消個人帳密】低年級不記帳號！每組 1 台貼顏色標籤的公用平板，掃 QR-code 直接進任務畫面。</a:t>
             </a:r>
           </a:p>
@@ -8528,6 +8659,7 @@
               </a:defRPr>
             </a:pPr>
             <a:r>
+              <a:rPr/>
               <a:t>2. 【語音輸入代替打字】學生按麥克風說話自動轉文字，識字量少也能暢所欲言表達思維。</a:t>
             </a:r>
           </a:p>
@@ -8544,6 +8676,7 @@
               </a:defRPr>
             </a:pPr>
             <a:r>
+              <a:rPr/>
               <a:t>3. 【拍照代替複雜操作】實體積木、小白板擺好後，小組『按拍照鍵』直接上傳，3 秒完成記錄！</a:t>
             </a:r>
           </a:p>
@@ -8625,6 +8758,7 @@
               </a:defRPr>
             </a:pPr>
             <a:r>
+              <a:rPr/>
               <a:t>❓ 科任/資深老師提問：</a:t>
             </a:r>
           </a:p>
@@ -8641,6 +8775,7 @@
               </a:defRPr>
             </a:pPr>
             <a:r>
+              <a:rPr/>
               <a:t>「如何設計互動小遊戲且不耗費許多時間？」</a:t>
             </a:r>
           </a:p>
@@ -8657,6 +8792,7 @@
               </a:defRPr>
             </a:pPr>
             <a:r>
+              <a:rPr/>
               <a:t>💡 輔導團三階落地解方：</a:t>
             </a:r>
           </a:p>
@@ -8673,6 +8809,7 @@
               </a:defRPr>
             </a:pPr>
             <a:r>
+              <a:rPr/>
               <a:t>1. 【AI 餵料 1 分鐘生題庫】將課本貼給 Gemini：『產生 5 題四選一選擇題』，複製直接匯入 Wordwall。</a:t>
             </a:r>
           </a:p>
@@ -8689,6 +8826,7 @@
               </a:defRPr>
             </a:pPr>
             <a:r>
+              <a:rPr/>
               <a:t>2. 【Wordwall 一鍵換造型】貼入一次題目，系統自動切換打地鼠、輪盤、連連看，免重複備課！</a:t>
             </a:r>
           </a:p>
@@ -8705,6 +8843,7 @@
               </a:defRPr>
             </a:pPr>
             <a:r>
+              <a:rPr/>
               <a:t>3. 【86吋大螢幕雙人擂台】免發平板！兩位學生直接上台在大螢幕觸控搶答，全班同步觀戰思辨！</a:t>
             </a:r>
           </a:p>

</xml_diff>